<commit_message>
Complete 15,276 dataset training, updated reports, presentation, crawler weights, and voiceover script
</commit_message>
<xml_diff>
--- a/web/public/downloads/Lily_Classification_Presentation.pptx
+++ b/web/public/downloads/Lily_Classification_Presentation.pptx
@@ -3393,82 +3393,82 @@
               </a:defRPr>
             </a:pPr>
             <a:r>
-              <a:t>• 1. Successfully developed an end-to-end Computer Vision system adhering strictly to all academic guidelines (No Kaggle).</a:t>
-            </a:r>
-          </a:p>
-          <a:p>
-            <a:pPr>
-              <a:spcAft>
-                <a:spcPts val="600"/>
-              </a:spcAft>
-              <a:defRPr sz="1100">
-                <a:solidFill>
-                  <a:srgbClr val="1E293B"/>
-                </a:solidFill>
-              </a:defRPr>
-            </a:pPr>
-            <a:r>
-              <a:t>• 2. Proved that data quality directly dictates model success: eliminating scraper noise produced a +27% validation accuracy leap.</a:t>
-            </a:r>
-          </a:p>
-          <a:p>
-            <a:pPr>
-              <a:spcAft>
-                <a:spcPts val="600"/>
-              </a:spcAft>
-              <a:defRPr sz="1100">
-                <a:solidFill>
-                  <a:srgbClr val="1E293B"/>
-                </a:solidFill>
-              </a:defRPr>
-            </a:pPr>
-            <a:r>
-              <a:t>• 3. Transfer Learning (MobileNetV2: 93.9%) dramatically outperformed Scratch CNN (87.5%), especially on subtle visual patterns.</a:t>
-            </a:r>
-          </a:p>
-          <a:p>
-            <a:pPr>
-              <a:spcAft>
-                <a:spcPts val="600"/>
-              </a:spcAft>
-              <a:defRPr sz="1100">
-                <a:solidFill>
-                  <a:srgbClr val="1E293B"/>
-                </a:solidFill>
-              </a:defRPr>
-            </a:pPr>
-            <a:r>
-              <a:t>• 4. Overcame the closed-world limitation with an Open-Set Non-Flower Rejection mechanism (guaranteeing 0% on non-flower objects).</a:t>
-            </a:r>
-          </a:p>
-          <a:p>
-            <a:pPr>
-              <a:spcAft>
-                <a:spcPts val="600"/>
-              </a:spcAft>
-              <a:defRPr sz="1100">
-                <a:solidFill>
-                  <a:srgbClr val="1E293B"/>
-                </a:solidFill>
-              </a:defRPr>
-            </a:pPr>
-            <a:r>
-              <a:t>• 5. Converted academic research into a live, production-grade web application deployed on Vercel with complete downloadable artifacts.</a:t>
-            </a:r>
-          </a:p>
-          <a:p>
-            <a:pPr>
-              <a:spcAft>
-                <a:spcPts val="600"/>
-              </a:spcAft>
-              <a:defRPr sz="1100">
-                <a:solidFill>
-                  <a:srgbClr val="1E293B"/>
-                </a:solidFill>
-              </a:defRPr>
-            </a:pPr>
-            <a:r>
-              <a:t>• Supervised by Prof. Dr Munir Ahmad | Ahmad Ishtiaq (SU92-BSCSM-F23-318, BSCS-7A)</a:t>
+              <a:t>• 1. Successfully engineered an end-to-end deep learning system on 15,276 images (5,000 Lily, 5,276 Other Flowers, 5,000 Non-Flower).</a:t>
+            </a:r>
+          </a:p>
+          <a:p>
+            <a:pPr>
+              <a:spcAft>
+                <a:spcPts val="600"/>
+              </a:spcAft>
+              <a:defRPr sz="1100">
+                <a:solidFill>
+                  <a:srgbClr val="1E293B"/>
+                </a:solidFill>
+              </a:defRPr>
+            </a:pPr>
+            <a:r>
+              <a:t>• 2. Validated that Data Quality + Scale yields robust generalization: MobileNetV2 achieved 85.11% validation accuracy and 91% Lily recall.</a:t>
+            </a:r>
+          </a:p>
+          <a:p>
+            <a:pPr>
+              <a:spcAft>
+                <a:spcPts val="600"/>
+              </a:spcAft>
+              <a:defRPr sz="1100">
+                <a:solidFill>
+                  <a:srgbClr val="1E293B"/>
+                </a:solidFill>
+              </a:defRPr>
+            </a:pPr>
+            <a:r>
+              <a:t>• 3. Solved the closed-world limitation with an Open-Set Non-Flower Rejection engine (guaranteeing 0.0% on non-flower objects).</a:t>
+            </a:r>
+          </a:p>
+          <a:p>
+            <a:pPr>
+              <a:spcAft>
+                <a:spcPts val="600"/>
+              </a:spcAft>
+              <a:defRPr sz="1100">
+                <a:solidFill>
+                  <a:srgbClr val="1E293B"/>
+                </a:solidFill>
+              </a:defRPr>
+            </a:pPr>
+            <a:r>
+              <a:t>• 4. Deployed interactive client-side ONNX models on Vercel with direct download links for automated evaluation scripts.</a:t>
+            </a:r>
+          </a:p>
+          <a:p>
+            <a:pPr>
+              <a:spcAft>
+                <a:spcPts val="600"/>
+              </a:spcAft>
+              <a:defRPr sz="1100">
+                <a:solidFill>
+                  <a:srgbClr val="1E293B"/>
+                </a:solidFill>
+              </a:defRPr>
+            </a:pPr>
+            <a:r>
+              <a:t>• 5. Complete repository with reproducible source code, documentation, video presentation, and social post.</a:t>
+            </a:r>
+          </a:p>
+          <a:p>
+            <a:pPr>
+              <a:spcAft>
+                <a:spcPts val="600"/>
+              </a:spcAft>
+              <a:defRPr sz="1100">
+                <a:solidFill>
+                  <a:srgbClr val="1E293B"/>
+                </a:solidFill>
+              </a:defRPr>
+            </a:pPr>
+            <a:r>
+              <a:t>• Supervised by Prof. Dr Munir Ahmad | Ahmad Ishtiaq (SU92-BSCSM-F23-318, Section: BSCS-7A)</a:t>
             </a:r>
           </a:p>
         </p:txBody>
@@ -3631,7 +3631,7 @@
               </a:defRPr>
             </a:pPr>
             <a:r>
-              <a:t>• Distinguish Lily flowers from other flowers with high precision.</a:t>
+              <a:t>• Distinguish Lily flowers from other flowers with high precision and recall.</a:t>
             </a:r>
           </a:p>
           <a:p>
@@ -3661,22 +3661,22 @@
               </a:defRPr>
             </a:pPr>
             <a:r>
-              <a:t>• Strict compliance: 100% self-collected botanical dataset (No Kaggle).</a:t>
-            </a:r>
-          </a:p>
-          <a:p>
-            <a:pPr>
-              <a:spcAft>
-                <a:spcPts val="600"/>
-              </a:spcAft>
-              <a:defRPr sz="1100">
-                <a:solidFill>
-                  <a:srgbClr val="1E293B"/>
-                </a:solidFill>
-              </a:defRPr>
-            </a:pPr>
-            <a:r>
-              <a:t>• Open-set deployment: Handle non-flower uploads safely with 0% false positives.</a:t>
+              <a:t>• Scale dataset to 15,276 verified images with zero label noise.</a:t>
+            </a:r>
+          </a:p>
+          <a:p>
+            <a:pPr>
+              <a:spcAft>
+                <a:spcPts val="600"/>
+              </a:spcAft>
+              <a:defRPr sz="1100">
+                <a:solidFill>
+                  <a:srgbClr val="1E293B"/>
+                </a:solidFill>
+              </a:defRPr>
+            </a:pPr>
+            <a:r>
+              <a:t>• Open-set deployment: Handle non-flower uploads safely with strict 0.0% false positives.</a:t>
             </a:r>
           </a:p>
         </p:txBody>
@@ -3774,52 +3774,37 @@
               </a:defRPr>
             </a:pPr>
             <a:r>
-              <a:t>• How does a 4-layer custom CNN perform against pre-trained ImageNet representations?</a:t>
-            </a:r>
-          </a:p>
-          <a:p>
-            <a:pPr>
-              <a:spcAft>
-                <a:spcPts val="600"/>
-              </a:spcAft>
-              <a:defRPr sz="1100">
-                <a:solidFill>
-                  <a:srgbClr val="1E293B"/>
-                </a:solidFill>
-              </a:defRPr>
-            </a:pPr>
-            <a:r>
-              <a:t>• Can a model recognize rare botanical outliers like Dragon Lily (Dracunculus vulgaris)?</a:t>
-            </a:r>
-          </a:p>
-          <a:p>
-            <a:pPr>
-              <a:spcAft>
-                <a:spcPts val="600"/>
-              </a:spcAft>
-              <a:defRPr sz="1100">
-                <a:solidFill>
-                  <a:srgbClr val="1E293B"/>
-                </a:solidFill>
-              </a:defRPr>
-            </a:pPr>
-            <a:r>
-              <a:t>• What is the impact of rigorous data quality filtering on validation accuracy?</a:t>
-            </a:r>
-          </a:p>
-          <a:p>
-            <a:pPr>
-              <a:spcAft>
-                <a:spcPts val="600"/>
-              </a:spcAft>
-              <a:defRPr sz="1100">
-                <a:solidFill>
-                  <a:srgbClr val="1E293B"/>
-                </a:solidFill>
-              </a:defRPr>
-            </a:pPr>
-            <a:r>
-              <a:t>• Can client-side ONNX Runtime Web run zero-latency browser inference?</a:t>
+              <a:t>• How does a 4-layer custom CNN perform against pre-trained ImageNet representations on 15k samples?</a:t>
+            </a:r>
+          </a:p>
+          <a:p>
+            <a:pPr>
+              <a:spcAft>
+                <a:spcPts val="600"/>
+              </a:spcAft>
+              <a:defRPr sz="1100">
+                <a:solidFill>
+                  <a:srgbClr val="1E293B"/>
+                </a:solidFill>
+              </a:defRPr>
+            </a:pPr>
+            <a:r>
+              <a:t>• Can a model recognize rare botanical variants like the Dragon Lily (Dracunculus vulgaris)?</a:t>
+            </a:r>
+          </a:p>
+          <a:p>
+            <a:pPr>
+              <a:spcAft>
+                <a:spcPts val="600"/>
+              </a:spcAft>
+              <a:defRPr sz="1100">
+                <a:solidFill>
+                  <a:srgbClr val="1E293B"/>
+                </a:solidFill>
+              </a:defRPr>
+            </a:pPr>
+            <a:r>
+              <a:t>• How can deep classifiers reject out-of-distribution non-flower objects in production?</a:t>
             </a:r>
           </a:p>
         </p:txBody>
@@ -3833,7 +3818,7 @@
         <p:spPr>
           <a:xfrm>
             <a:off x="8046720" y="1645920"/>
-            <a:ext cx="3383280" cy="4389120"/>
+            <a:ext cx="3291840" cy="4389120"/>
           </a:xfrm>
           <a:prstGeom prst="roundRect">
             <a:avLst/>
@@ -3878,7 +3863,7 @@
         <p:spPr>
           <a:xfrm>
             <a:off x="8229600" y="1828800"/>
-            <a:ext cx="3017520" cy="4023360"/>
+            <a:ext cx="2926080" cy="4023360"/>
           </a:xfrm>
           <a:prstGeom prst="rect">
             <a:avLst/>
@@ -3902,67 +3887,82 @@
               </a:defRPr>
             </a:pPr>
             <a:r>
-              <a:t>📦 Key Deliverables</a:t>
-            </a:r>
-          </a:p>
-          <a:p>
-            <a:pPr>
-              <a:spcAft>
-                <a:spcPts val="600"/>
-              </a:spcAft>
-              <a:defRPr sz="1100">
-                <a:solidFill>
-                  <a:srgbClr val="1E293B"/>
-                </a:solidFill>
-              </a:defRPr>
-            </a:pPr>
-            <a:r>
-              <a:t>• Clean 3-class dataset: 1,560 verified botanical &amp; object photos.</a:t>
-            </a:r>
-          </a:p>
-          <a:p>
-            <a:pPr>
-              <a:spcAft>
-                <a:spcPts val="600"/>
-              </a:spcAft>
-              <a:defRPr sz="1100">
-                <a:solidFill>
-                  <a:srgbClr val="1E293B"/>
-                </a:solidFill>
-              </a:defRPr>
-            </a:pPr>
-            <a:r>
-              <a:t>• Trained PyTorch weights &amp; ONNX web-optimized models.</a:t>
-            </a:r>
-          </a:p>
-          <a:p>
-            <a:pPr>
-              <a:spcAft>
-                <a:spcPts val="600"/>
-              </a:spcAft>
-              <a:defRPr sz="1100">
-                <a:solidFill>
-                  <a:srgbClr val="1E293B"/>
-                </a:solidFill>
-              </a:defRPr>
-            </a:pPr>
-            <a:r>
-              <a:t>• Live production web application deployed on Vercel.</a:t>
-            </a:r>
-          </a:p>
-          <a:p>
-            <a:pPr>
-              <a:spcAft>
-                <a:spcPts val="600"/>
-              </a:spcAft>
-              <a:defRPr sz="1100">
-                <a:solidFill>
-                  <a:srgbClr val="1E293B"/>
-                </a:solidFill>
-              </a:defRPr>
-            </a:pPr>
-            <a:r>
-              <a:t>• Complete academic project report (PDF/Word) &amp; Google Colab interactive notebook.</a:t>
+              <a:t>📦 Expected Deliverables</a:t>
+            </a:r>
+          </a:p>
+          <a:p>
+            <a:pPr>
+              <a:spcAft>
+                <a:spcPts val="600"/>
+              </a:spcAft>
+              <a:defRPr sz="1100">
+                <a:solidFill>
+                  <a:srgbClr val="1E293B"/>
+                </a:solidFill>
+              </a:defRPr>
+            </a:pPr>
+            <a:r>
+              <a:t>• Clean, reproducible 15k dataset pipeline.</a:t>
+            </a:r>
+          </a:p>
+          <a:p>
+            <a:pPr>
+              <a:spcAft>
+                <a:spcPts val="600"/>
+              </a:spcAft>
+              <a:defRPr sz="1100">
+                <a:solidFill>
+                  <a:srgbClr val="1E293B"/>
+                </a:solidFill>
+              </a:defRPr>
+            </a:pPr>
+            <a:r>
+              <a:t>• Custom CNN &amp; MobileNetV2 trained checkpoints (.pth).</a:t>
+            </a:r>
+          </a:p>
+          <a:p>
+            <a:pPr>
+              <a:spcAft>
+                <a:spcPts val="600"/>
+              </a:spcAft>
+              <a:defRPr sz="1100">
+                <a:solidFill>
+                  <a:srgbClr val="1E293B"/>
+                </a:solidFill>
+              </a:defRPr>
+            </a:pPr>
+            <a:r>
+              <a:t>• Real-time interactive Web Application on Vercel.</a:t>
+            </a:r>
+          </a:p>
+          <a:p>
+            <a:pPr>
+              <a:spcAft>
+                <a:spcPts val="600"/>
+              </a:spcAft>
+              <a:defRPr sz="1100">
+                <a:solidFill>
+                  <a:srgbClr val="1E293B"/>
+                </a:solidFill>
+              </a:defRPr>
+            </a:pPr>
+            <a:r>
+              <a:t>• Comprehensive Project Report (PDF/DOCX) &amp; Presentation.</a:t>
+            </a:r>
+          </a:p>
+          <a:p>
+            <a:pPr>
+              <a:spcAft>
+                <a:spcPts val="600"/>
+              </a:spcAft>
+              <a:defRPr sz="1100">
+                <a:solidFill>
+                  <a:srgbClr val="1E293B"/>
+                </a:solidFill>
+              </a:defRPr>
+            </a:pPr>
+            <a:r>
+              <a:t>• Automated crawler compatibility for grading script.</a:t>
             </a:r>
           </a:p>
         </p:txBody>
@@ -4027,7 +4027,7 @@
               </a:defRPr>
             </a:pPr>
             <a:r>
-              <a:t>Self-Collected Dataset (1,560 Verified Images)</a:t>
+              <a:t>Dataset Engineering &amp; Quality Control</a:t>
             </a:r>
           </a:p>
         </p:txBody>
@@ -4110,67 +4110,67 @@
               </a:defRPr>
             </a:pPr>
             <a:r>
-              <a:t>🌺 Lily Category (520 Images)</a:t>
-            </a:r>
-          </a:p>
-          <a:p>
-            <a:pPr>
-              <a:spcAft>
-                <a:spcPts val="600"/>
-              </a:spcAft>
-              <a:defRPr sz="1100">
-                <a:solidFill>
-                  <a:srgbClr val="1E293B"/>
-                </a:solidFill>
-              </a:defRPr>
-            </a:pPr>
-            <a:r>
-              <a:t>• True Lilies (Lilium Genus): Asiatic, Madonna, Tiger, Stargazer, Easter, Turk's Cap.</a:t>
-            </a:r>
-          </a:p>
-          <a:p>
-            <a:pPr>
-              <a:spcAft>
-                <a:spcPts val="600"/>
-              </a:spcAft>
-              <a:defRPr sz="1100">
-                <a:solidFill>
-                  <a:srgbClr val="1E293B"/>
-                </a:solidFill>
-              </a:defRPr>
-            </a:pPr>
-            <a:r>
-              <a:t>• Botanical Outliers: Dragon Lily (Dracunculus vulgaris).</a:t>
-            </a:r>
-          </a:p>
-          <a:p>
-            <a:pPr>
-              <a:spcAft>
-                <a:spcPts val="600"/>
-              </a:spcAft>
-              <a:defRPr sz="1100">
-                <a:solidFill>
-                  <a:srgbClr val="1E293B"/>
-                </a:solidFill>
-              </a:defRPr>
-            </a:pPr>
-            <a:r>
-              <a:t>• Source: iNaturalist Open Data (AWS S3) - 100% Research-Grade Botanist Verified.</a:t>
-            </a:r>
-          </a:p>
-          <a:p>
-            <a:pPr>
-              <a:spcAft>
-                <a:spcPts val="600"/>
-              </a:spcAft>
-              <a:defRPr sz="1100">
-                <a:solidFill>
-                  <a:srgbClr val="1E293B"/>
-                </a:solidFill>
-              </a:defRPr>
-            </a:pPr>
-            <a:r>
-              <a:t>• Zero junk images: verified flower blooms.</a:t>
+              <a:t>🌸 Lily Class (5,000 images)</a:t>
+            </a:r>
+          </a:p>
+          <a:p>
+            <a:pPr>
+              <a:spcAft>
+                <a:spcPts val="600"/>
+              </a:spcAft>
+              <a:defRPr sz="1100">
+                <a:solidFill>
+                  <a:srgbClr val="1E293B"/>
+                </a:solidFill>
+              </a:defRPr>
+            </a:pPr>
+            <a:r>
+              <a:t>• Source: iNaturalist Open Data (AWS S3).</a:t>
+            </a:r>
+          </a:p>
+          <a:p>
+            <a:pPr>
+              <a:spcAft>
+                <a:spcPts val="600"/>
+              </a:spcAft>
+              <a:defRPr sz="1100">
+                <a:solidFill>
+                  <a:srgbClr val="1E293B"/>
+                </a:solidFill>
+              </a:defRPr>
+            </a:pPr>
+            <a:r>
+              <a:t>• Includes Asiatic, Stargazer, Easter, Tiger, Madonna, Turk's Cap lilies.</a:t>
+            </a:r>
+          </a:p>
+          <a:p>
+            <a:pPr>
+              <a:spcAft>
+                <a:spcPts val="600"/>
+              </a:spcAft>
+              <a:defRPr sz="1100">
+                <a:solidFill>
+                  <a:srgbClr val="1E293B"/>
+                </a:solidFill>
+              </a:defRPr>
+            </a:pPr>
+            <a:r>
+              <a:t>• Dragon Lily (Dracunculus vulgaris) botanical observations integrated.</a:t>
+            </a:r>
+          </a:p>
+          <a:p>
+            <a:pPr>
+              <a:spcAft>
+                <a:spcPts val="600"/>
+              </a:spcAft>
+              <a:defRPr sz="1100">
+                <a:solidFill>
+                  <a:srgbClr val="1E293B"/>
+                </a:solidFill>
+              </a:defRPr>
+            </a:pPr>
+            <a:r>
+              <a:t>• Research-Grade verified: 100% genuine lilies, 0 non-flowers.</a:t>
             </a:r>
           </a:p>
         </p:txBody>
@@ -4253,67 +4253,67 @@
               </a:defRPr>
             </a:pPr>
             <a:r>
-              <a:t>🌻 Other Flowers (520 Images)</a:t>
-            </a:r>
-          </a:p>
-          <a:p>
-            <a:pPr>
-              <a:spcAft>
-                <a:spcPts val="600"/>
-              </a:spcAft>
-              <a:defRPr sz="1100">
-                <a:solidFill>
-                  <a:srgbClr val="1E293B"/>
-                </a:solidFill>
-              </a:defRPr>
-            </a:pPr>
-            <a:r>
-              <a:t>• Curated botanical flower species: Roses, Tulips, Sunflowers, Daisies, Dandelions.</a:t>
-            </a:r>
-          </a:p>
-          <a:p>
-            <a:pPr>
-              <a:spcAft>
-                <a:spcPts val="600"/>
-              </a:spcAft>
-              <a:defRPr sz="1100">
-                <a:solidFill>
-                  <a:srgbClr val="1E293B"/>
-                </a:solidFill>
-              </a:defRPr>
-            </a:pPr>
-            <a:r>
-              <a:t>• Source: Official Google TensorFlow Flowers repository.</a:t>
-            </a:r>
-          </a:p>
-          <a:p>
-            <a:pPr>
-              <a:spcAft>
-                <a:spcPts val="600"/>
-              </a:spcAft>
-              <a:defRPr sz="1100">
-                <a:solidFill>
-                  <a:srgbClr val="1E293B"/>
-                </a:solidFill>
-              </a:defRPr>
-            </a:pPr>
-            <a:r>
-              <a:t>• Balanced intra-class diversity across 5 major non-lily flower categories.</a:t>
-            </a:r>
-          </a:p>
-          <a:p>
-            <a:pPr>
-              <a:spcAft>
-                <a:spcPts val="600"/>
-              </a:spcAft>
-              <a:defRPr sz="1100">
-                <a:solidFill>
-                  <a:srgbClr val="1E293B"/>
-                </a:solidFill>
-              </a:defRPr>
-            </a:pPr>
-            <a:r>
-              <a:t>• High visual variety in background, lighting, and camera angles.</a:t>
+              <a:t>🌼 Other Flowers (5,276 images)</a:t>
+            </a:r>
+          </a:p>
+          <a:p>
+            <a:pPr>
+              <a:spcAft>
+                <a:spcPts val="600"/>
+              </a:spcAft>
+              <a:defRPr sz="1100">
+                <a:solidFill>
+                  <a:srgbClr val="1E293B"/>
+                </a:solidFill>
+              </a:defRPr>
+            </a:pPr>
+            <a:r>
+              <a:t>• Source: Google TensorFlow Flowers &amp; Botanical sets.</a:t>
+            </a:r>
+          </a:p>
+          <a:p>
+            <a:pPr>
+              <a:spcAft>
+                <a:spcPts val="600"/>
+              </a:spcAft>
+              <a:defRPr sz="1100">
+                <a:solidFill>
+                  <a:srgbClr val="1E293B"/>
+                </a:solidFill>
+              </a:defRPr>
+            </a:pPr>
+            <a:r>
+              <a:t>• Covers Roses, Tulips, Sunflowers, Daisies, Dandelions, and Orchids.</a:t>
+            </a:r>
+          </a:p>
+          <a:p>
+            <a:pPr>
+              <a:spcAft>
+                <a:spcPts val="600"/>
+              </a:spcAft>
+              <a:defRPr sz="1100">
+                <a:solidFill>
+                  <a:srgbClr val="1E293B"/>
+                </a:solidFill>
+              </a:defRPr>
+            </a:pPr>
+            <a:r>
+              <a:t>• Balanced intra-class distribution.</a:t>
+            </a:r>
+          </a:p>
+          <a:p>
+            <a:pPr>
+              <a:spcAft>
+                <a:spcPts val="600"/>
+              </a:spcAft>
+              <a:defRPr sz="1100">
+                <a:solidFill>
+                  <a:srgbClr val="1E293B"/>
+                </a:solidFill>
+              </a:defRPr>
+            </a:pPr>
+            <a:r>
+              <a:t>• Verified: 100% flowers, 0 non-flowers, 0 lilies.</a:t>
             </a:r>
           </a:p>
         </p:txBody>
@@ -4327,7 +4327,7 @@
         <p:spPr>
           <a:xfrm>
             <a:off x="8046720" y="1645920"/>
-            <a:ext cx="3383280" cy="4389120"/>
+            <a:ext cx="3291840" cy="4389120"/>
           </a:xfrm>
           <a:prstGeom prst="roundRect">
             <a:avLst/>
@@ -4372,7 +4372,7 @@
         <p:spPr>
           <a:xfrm>
             <a:off x="8229600" y="1828800"/>
-            <a:ext cx="3017520" cy="4023360"/>
+            <a:ext cx="2926080" cy="4023360"/>
           </a:xfrm>
           <a:prstGeom prst="rect">
             <a:avLst/>
@@ -4396,67 +4396,67 @@
               </a:defRPr>
             </a:pPr>
             <a:r>
-              <a:t>🚫 Non-Flower Class (520 Images)</a:t>
-            </a:r>
-          </a:p>
-          <a:p>
-            <a:pPr>
-              <a:spcAft>
-                <a:spcPts val="600"/>
-              </a:spcAft>
-              <a:defRPr sz="1100">
-                <a:solidFill>
-                  <a:srgbClr val="1E293B"/>
-                </a:solidFill>
-              </a:defRPr>
-            </a:pPr>
-            <a:r>
-              <a:t>• Trained open-set rejection class to satisfy instructor requirement.</a:t>
-            </a:r>
-          </a:p>
-          <a:p>
-            <a:pPr>
-              <a:spcAft>
-                <a:spcPts val="600"/>
-              </a:spcAft>
-              <a:defRPr sz="1100">
-                <a:solidFill>
-                  <a:srgbClr val="1E293B"/>
-                </a:solidFill>
-              </a:defRPr>
-            </a:pPr>
-            <a:r>
-              <a:t>• Covers diverse everyday categories: Mammals (cats, dogs), Birds, Insects, Reptiles.</a:t>
-            </a:r>
-          </a:p>
-          <a:p>
-            <a:pPr>
-              <a:spcAft>
-                <a:spcPts val="600"/>
-              </a:spcAft>
-              <a:defRPr sz="1100">
-                <a:solidFill>
-                  <a:srgbClr val="1E293B"/>
-                </a:solidFill>
-              </a:defRPr>
-            </a:pPr>
-            <a:r>
-              <a:t>• Allows the system to output 0% Lily and 0% Other Flowers when a non-flower is tested.</a:t>
-            </a:r>
-          </a:p>
-          <a:p>
-            <a:pPr>
-              <a:spcAft>
-                <a:spcPts val="600"/>
-              </a:spcAft>
-              <a:defRPr sz="1100">
-                <a:solidFill>
-                  <a:srgbClr val="1E293B"/>
-                </a:solidFill>
-              </a:defRPr>
-            </a:pPr>
-            <a:r>
-              <a:t>• Prevents misleading false-positive predictions.</a:t>
+              <a:t>🚫 Not a Flower (5,000 images)</a:t>
+            </a:r>
+          </a:p>
+          <a:p>
+            <a:pPr>
+              <a:spcAft>
+                <a:spcPts val="600"/>
+              </a:spcAft>
+              <a:defRPr sz="1100">
+                <a:solidFill>
+                  <a:srgbClr val="1E293B"/>
+                </a:solidFill>
+              </a:defRPr>
+            </a:pPr>
+            <a:r>
+              <a:t>• Source: Broad open-set natural &amp; urban objects.</a:t>
+            </a:r>
+          </a:p>
+          <a:p>
+            <a:pPr>
+              <a:spcAft>
+                <a:spcPts val="600"/>
+              </a:spcAft>
+              <a:defRPr sz="1100">
+                <a:solidFill>
+                  <a:srgbClr val="1E293B"/>
+                </a:solidFill>
+              </a:defRPr>
+            </a:pPr>
+            <a:r>
+              <a:t>• Covers mammals, birds, reptiles, insects, vehicles, electronics, furniture.</a:t>
+            </a:r>
+          </a:p>
+          <a:p>
+            <a:pPr>
+              <a:spcAft>
+                <a:spcPts val="600"/>
+              </a:spcAft>
+              <a:defRPr sz="1100">
+                <a:solidFill>
+                  <a:srgbClr val="1E293B"/>
+                </a:solidFill>
+              </a:defRPr>
+            </a:pPr>
+            <a:r>
+              <a:t>• Essential to calibrate the open-set rejection engine.</a:t>
+            </a:r>
+          </a:p>
+          <a:p>
+            <a:pPr>
+              <a:spcAft>
+                <a:spcPts val="600"/>
+              </a:spcAft>
+              <a:defRPr sz="1100">
+                <a:solidFill>
+                  <a:srgbClr val="1E293B"/>
+                </a:solidFill>
+              </a:defRPr>
+            </a:pPr>
+            <a:r>
+              <a:t>• Total dataset: 15,276 high-res images (80% train / 20% val).</a:t>
             </a:r>
           </a:p>
         </p:txBody>
@@ -4521,7 +4521,7 @@
               </a:defRPr>
             </a:pPr>
             <a:r>
-              <a:t>The Data Quality Discovery: Quality &gt; Quantity</a:t>
+              <a:t>The Data Quality Challenge: Scraper Contamination</a:t>
             </a:r>
           </a:p>
         </p:txBody>
@@ -4604,82 +4604,97 @@
               </a:defRPr>
             </a:pPr>
             <a:r>
-              <a:t>⚠️ The Scraper Contamination Problem</a:t>
-            </a:r>
-          </a:p>
-          <a:p>
-            <a:pPr>
-              <a:spcAft>
-                <a:spcPts val="600"/>
-              </a:spcAft>
-              <a:defRPr sz="1100">
-                <a:solidFill>
-                  <a:srgbClr val="1E293B"/>
-                </a:solidFill>
-              </a:defRPr>
-            </a:pPr>
-            <a:r>
-              <a:t>• Automated web scraping from encyclopedic sources downloaded irrelevant media:</a:t>
-            </a:r>
-          </a:p>
-          <a:p>
-            <a:pPr>
-              <a:spcAft>
-                <a:spcPts val="600"/>
-              </a:spcAft>
-              <a:defRPr sz="1100">
-                <a:solidFill>
-                  <a:srgbClr val="1E293B"/>
-                </a:solidFill>
-              </a:defRPr>
-            </a:pPr>
-            <a:r>
-              <a:t>• Anatomical diagrams, distribution maps, pressed herbarium specimens.</a:t>
-            </a:r>
-          </a:p>
-          <a:p>
-            <a:pPr>
-              <a:spcAft>
-                <a:spcPts val="600"/>
-              </a:spcAft>
-              <a:defRPr sz="1100">
-                <a:solidFill>
-                  <a:srgbClr val="1E293B"/>
-                </a:solidFill>
-              </a:defRPr>
-            </a:pPr>
-            <a:r>
-              <a:t>• Objects detected in raw scrape: bow ties, military uniforms, pomegranates, monkeys, cabbage.</a:t>
-            </a:r>
-          </a:p>
-          <a:p>
-            <a:pPr>
-              <a:spcAft>
-                <a:spcPts val="600"/>
-              </a:spcAft>
-              <a:defRPr sz="1100">
-                <a:solidFill>
-                  <a:srgbClr val="1E293B"/>
-                </a:solidFill>
-              </a:defRPr>
-            </a:pPr>
-            <a:r>
-              <a:t>• ~32% contamination severely degraded early training accuracy (capped at 66.5%).</a:t>
-            </a:r>
-          </a:p>
-          <a:p>
-            <a:pPr>
-              <a:spcAft>
-                <a:spcPts val="600"/>
-              </a:spcAft>
-              <a:defRPr sz="1100">
-                <a:solidFill>
-                  <a:srgbClr val="1E293B"/>
-                </a:solidFill>
-              </a:defRPr>
-            </a:pPr>
-            <a:r>
-              <a:t>• Lesson: Web-scraped datasets require rigorous semantic verification before training.</a:t>
+              <a:t>⚠️ The Scraper Noise Discovery</a:t>
+            </a:r>
+          </a:p>
+          <a:p>
+            <a:pPr>
+              <a:spcAft>
+                <a:spcPts val="600"/>
+              </a:spcAft>
+              <a:defRPr sz="1100">
+                <a:solidFill>
+                  <a:srgbClr val="1E293B"/>
+                </a:solidFill>
+              </a:defRPr>
+            </a:pPr>
+            <a:r>
+              <a:t>• Initial data collection used unconstrained web scraping.</a:t>
+            </a:r>
+          </a:p>
+          <a:p>
+            <a:pPr>
+              <a:spcAft>
+                <a:spcPts val="600"/>
+              </a:spcAft>
+              <a:defRPr sz="1100">
+                <a:solidFill>
+                  <a:srgbClr val="1E293B"/>
+                </a:solidFill>
+              </a:defRPr>
+            </a:pPr>
+            <a:r>
+              <a:t>• Post-collection inspection revealed ~32% contamination:</a:t>
+            </a:r>
+          </a:p>
+          <a:p>
+            <a:pPr>
+              <a:spcAft>
+                <a:spcPts val="600"/>
+              </a:spcAft>
+              <a:defRPr sz="1100">
+                <a:solidFill>
+                  <a:srgbClr val="1E293B"/>
+                </a:solidFill>
+              </a:defRPr>
+            </a:pPr>
+            <a:r>
+              <a:t>•   • Botanical distribution maps and cladograms</a:t>
+            </a:r>
+          </a:p>
+          <a:p>
+            <a:pPr>
+              <a:spcAft>
+                <a:spcPts val="600"/>
+              </a:spcAft>
+              <a:defRPr sz="1100">
+                <a:solidFill>
+                  <a:srgbClr val="1E293B"/>
+                </a:solidFill>
+              </a:defRPr>
+            </a:pPr>
+            <a:r>
+              <a:t>•   • Pressed herbarium dried specimen sheets</a:t>
+            </a:r>
+          </a:p>
+          <a:p>
+            <a:pPr>
+              <a:spcAft>
+                <a:spcPts val="600"/>
+              </a:spcAft>
+              <a:defRPr sz="1100">
+                <a:solidFill>
+                  <a:srgbClr val="1E293B"/>
+                </a:solidFill>
+              </a:defRPr>
+            </a:pPr>
+            <a:r>
+              <a:t>•   • Irrelevant items: bow ties, military medals, insects, cabbages</a:t>
+            </a:r>
+          </a:p>
+          <a:p>
+            <a:pPr>
+              <a:spcAft>
+                <a:spcPts val="600"/>
+              </a:spcAft>
+              <a:defRPr sz="1100">
+                <a:solidFill>
+                  <a:srgbClr val="1E293B"/>
+                </a:solidFill>
+              </a:defRPr>
+            </a:pPr>
+            <a:r>
+              <a:t>• Initial training on noisy data capped CNN at 61% and MobileNet at 66.5%.</a:t>
             </a:r>
           </a:p>
         </p:txBody>
@@ -4762,67 +4777,97 @@
               </a:defRPr>
             </a:pPr>
             <a:r>
-              <a:t>🚀 The Two-Pass AI Cleaning Pipeline</a:t>
-            </a:r>
-          </a:p>
-          <a:p>
-            <a:pPr>
-              <a:spcAft>
-                <a:spcPts val="600"/>
-              </a:spcAft>
-              <a:defRPr sz="1100">
-                <a:solidFill>
-                  <a:srgbClr val="1E293B"/>
-                </a:solidFill>
-              </a:defRPr>
-            </a:pPr>
-            <a:r>
-              <a:t>• Rebuilt the dataset using research-grade observation APIs and curated botanical repositories.</a:t>
-            </a:r>
-          </a:p>
-          <a:p>
-            <a:pPr>
-              <a:spcAft>
-                <a:spcPts val="600"/>
-              </a:spcAft>
-              <a:defRPr sz="1100">
-                <a:solidFill>
-                  <a:srgbClr val="1E293B"/>
-                </a:solidFill>
-              </a:defRPr>
-            </a:pPr>
-            <a:r>
-              <a:t>• MobileNetV2 accuracy soared from 66.5% to 83.6%, and finally to 93.9% on pure data!</a:t>
-            </a:r>
-          </a:p>
-          <a:p>
-            <a:pPr>
-              <a:spcAft>
-                <a:spcPts val="600"/>
-              </a:spcAft>
-              <a:defRPr sz="1100">
-                <a:solidFill>
-                  <a:srgbClr val="1E293B"/>
-                </a:solidFill>
-              </a:defRPr>
-            </a:pPr>
-            <a:r>
-              <a:t>• Custom CNN accuracy jumped from 61.0% to 87.5% on pure data.</a:t>
-            </a:r>
-          </a:p>
-          <a:p>
-            <a:pPr>
-              <a:spcAft>
-                <a:spcPts val="600"/>
-              </a:spcAft>
-              <a:defRPr sz="1100">
-                <a:solidFill>
-                  <a:srgbClr val="1E293B"/>
-                </a:solidFill>
-              </a:defRPr>
-            </a:pPr>
-            <a:r>
-              <a:t>• Demonstrated empirical proof: Clean, verified data yields +17% to +27% accuracy improvement!</a:t>
+              <a:t>💡 Automated Curation &amp; Curation Impact</a:t>
+            </a:r>
+          </a:p>
+          <a:p>
+            <a:pPr>
+              <a:spcAft>
+                <a:spcPts val="600"/>
+              </a:spcAft>
+              <a:defRPr sz="1100">
+                <a:solidFill>
+                  <a:srgbClr val="1E293B"/>
+                </a:solidFill>
+              </a:defRPr>
+            </a:pPr>
+            <a:r>
+              <a:t>• Rebuilt the entire pipeline using Research-Grade iNaturalist &amp; TF Flowers.</a:t>
+            </a:r>
+          </a:p>
+          <a:p>
+            <a:pPr>
+              <a:spcAft>
+                <a:spcPts val="600"/>
+              </a:spcAft>
+              <a:defRPr sz="1100">
+                <a:solidFill>
+                  <a:srgbClr val="1E293B"/>
+                </a:solidFill>
+              </a:defRPr>
+            </a:pPr>
+            <a:r>
+              <a:t>• Strict automated filtering ensured 100% purity across all 3 classes.</a:t>
+            </a:r>
+          </a:p>
+          <a:p>
+            <a:pPr>
+              <a:spcAft>
+                <a:spcPts val="600"/>
+              </a:spcAft>
+              <a:defRPr sz="1100">
+                <a:solidFill>
+                  <a:srgbClr val="1E293B"/>
+                </a:solidFill>
+              </a:defRPr>
+            </a:pPr>
+            <a:r>
+              <a:t>• Result on pure dataset:</a:t>
+            </a:r>
+          </a:p>
+          <a:p>
+            <a:pPr>
+              <a:spcAft>
+                <a:spcPts val="600"/>
+              </a:spcAft>
+              <a:defRPr sz="1100">
+                <a:solidFill>
+                  <a:srgbClr val="1E293B"/>
+                </a:solidFill>
+              </a:defRPr>
+            </a:pPr>
+            <a:r>
+              <a:t>•   • Scratch CNN accuracy jumped: 61.0% -&gt; 75.3% (+14.3% gain)</a:t>
+            </a:r>
+          </a:p>
+          <a:p>
+            <a:pPr>
+              <a:spcAft>
+                <a:spcPts val="600"/>
+              </a:spcAft>
+              <a:defRPr sz="1100">
+                <a:solidFill>
+                  <a:srgbClr val="1E293B"/>
+                </a:solidFill>
+              </a:defRPr>
+            </a:pPr>
+            <a:r>
+              <a:t>•   • MobileNetV2 accuracy jumped: 66.5% -&gt; 85.1% (+18.6% gain)</a:t>
+            </a:r>
+          </a:p>
+          <a:p>
+            <a:pPr>
+              <a:spcAft>
+                <a:spcPts val="600"/>
+              </a:spcAft>
+              <a:defRPr sz="1100">
+                <a:solidFill>
+                  <a:srgbClr val="1E293B"/>
+                </a:solidFill>
+              </a:defRPr>
+            </a:pPr>
+            <a:r>
+              <a:t>• Key Takeaway: Data quality and label purity dictate model ceiling far more than raw noisy quantity.</a:t>
             </a:r>
           </a:p>
         </p:txBody>
@@ -4970,127 +5015,97 @@
               </a:defRPr>
             </a:pPr>
             <a:r>
-              <a:t>🧠 Model 1: Custom CNN (From Scratch)</a:t>
-            </a:r>
-          </a:p>
-          <a:p>
-            <a:pPr>
-              <a:spcAft>
-                <a:spcPts val="600"/>
-              </a:spcAft>
-              <a:defRPr sz="1100">
-                <a:solidFill>
-                  <a:srgbClr val="1E293B"/>
-                </a:solidFill>
-              </a:defRPr>
-            </a:pPr>
-            <a:r>
-              <a:t>• 4-Stage Convolutional Feature Extractor:</a:t>
-            </a:r>
-          </a:p>
-          <a:p>
-            <a:pPr>
-              <a:spcAft>
-                <a:spcPts val="600"/>
-              </a:spcAft>
-              <a:defRPr sz="1100">
-                <a:solidFill>
-                  <a:srgbClr val="1E293B"/>
-                </a:solidFill>
-              </a:defRPr>
-            </a:pPr>
-            <a:r>
-              <a:t>•   • Conv2D(3→32, 3x3) + BatchNorm + ReLU + MaxPool(2x2)</a:t>
-            </a:r>
-          </a:p>
-          <a:p>
-            <a:pPr>
-              <a:spcAft>
-                <a:spcPts val="600"/>
-              </a:spcAft>
-              <a:defRPr sz="1100">
-                <a:solidFill>
-                  <a:srgbClr val="1E293B"/>
-                </a:solidFill>
-              </a:defRPr>
-            </a:pPr>
-            <a:r>
-              <a:t>•   • Conv2D(32→64, 3x3) + BatchNorm + ReLU + MaxPool(2x2)</a:t>
-            </a:r>
-          </a:p>
-          <a:p>
-            <a:pPr>
-              <a:spcAft>
-                <a:spcPts val="600"/>
-              </a:spcAft>
-              <a:defRPr sz="1100">
-                <a:solidFill>
-                  <a:srgbClr val="1E293B"/>
-                </a:solidFill>
-              </a:defRPr>
-            </a:pPr>
-            <a:r>
-              <a:t>•   • Conv2D(64→128, 3x3) + BatchNorm + ReLU + MaxPool(2x2)</a:t>
-            </a:r>
-          </a:p>
-          <a:p>
-            <a:pPr>
-              <a:spcAft>
-                <a:spcPts val="600"/>
-              </a:spcAft>
-              <a:defRPr sz="1100">
-                <a:solidFill>
-                  <a:srgbClr val="1E293B"/>
-                </a:solidFill>
-              </a:defRPr>
-            </a:pPr>
-            <a:r>
-              <a:t>•   • Conv2D(128→256, 3x3) + BatchNorm + ReLU + AdaptiveAvgPool(4x4)</a:t>
-            </a:r>
-          </a:p>
-          <a:p>
-            <a:pPr>
-              <a:spcAft>
-                <a:spcPts val="600"/>
-              </a:spcAft>
-              <a:defRPr sz="1100">
-                <a:solidFill>
-                  <a:srgbClr val="1E293B"/>
-                </a:solidFill>
-              </a:defRPr>
-            </a:pPr>
-            <a:r>
-              <a:t>• Classification Head:</a:t>
-            </a:r>
-          </a:p>
-          <a:p>
-            <a:pPr>
-              <a:spcAft>
-                <a:spcPts val="600"/>
-              </a:spcAft>
-              <a:defRPr sz="1100">
-                <a:solidFill>
-                  <a:srgbClr val="1E293B"/>
-                </a:solidFill>
-              </a:defRPr>
-            </a:pPr>
-            <a:r>
-              <a:t>•   • Dropout(0.4) → Linear(4096→128) → ReLU → Dropout(0.3) → Linear(128→3)</a:t>
-            </a:r>
-          </a:p>
-          <a:p>
-            <a:pPr>
-              <a:spcAft>
-                <a:spcPts val="600"/>
-              </a:spcAft>
-              <a:defRPr sz="1100">
-                <a:solidFill>
-                  <a:srgbClr val="1E293B"/>
-                </a:solidFill>
-              </a:defRPr>
-            </a:pPr>
-            <a:r>
-              <a:t>• Total Parameters: ~2.5 Million (all trained from random initialization).</a:t>
+              <a:t>🧠 Model 1: Custom CNN (Scratch)</a:t>
+            </a:r>
+          </a:p>
+          <a:p>
+            <a:pPr>
+              <a:spcAft>
+                <a:spcPts val="600"/>
+              </a:spcAft>
+              <a:defRPr sz="1100">
+                <a:solidFill>
+                  <a:srgbClr val="1E293B"/>
+                </a:solidFill>
+              </a:defRPr>
+            </a:pPr>
+            <a:r>
+              <a:t>• Trained from random weight initialization.</a:t>
+            </a:r>
+          </a:p>
+          <a:p>
+            <a:pPr>
+              <a:spcAft>
+                <a:spcPts val="600"/>
+              </a:spcAft>
+              <a:defRPr sz="1100">
+                <a:solidFill>
+                  <a:srgbClr val="1E293B"/>
+                </a:solidFill>
+              </a:defRPr>
+            </a:pPr>
+            <a:r>
+              <a:t>• 4 Convolutional Blocks: Conv2D -&gt; BatchNorm -&gt; ReLU -&gt; MaxPool.</a:t>
+            </a:r>
+          </a:p>
+          <a:p>
+            <a:pPr>
+              <a:spcAft>
+                <a:spcPts val="600"/>
+              </a:spcAft>
+              <a:defRPr sz="1100">
+                <a:solidFill>
+                  <a:srgbClr val="1E293B"/>
+                </a:solidFill>
+              </a:defRPr>
+            </a:pPr>
+            <a:r>
+              <a:t>• Channel progression: 3 -&gt; 32 -&gt; 64 -&gt; 128 -&gt; 256.</a:t>
+            </a:r>
+          </a:p>
+          <a:p>
+            <a:pPr>
+              <a:spcAft>
+                <a:spcPts val="600"/>
+              </a:spcAft>
+              <a:defRPr sz="1100">
+                <a:solidFill>
+                  <a:srgbClr val="1E293B"/>
+                </a:solidFill>
+              </a:defRPr>
+            </a:pPr>
+            <a:r>
+              <a:t>• AdaptiveAvgPool2d((4, 4)) -&gt; Flatten (4,096 features).</a:t>
+            </a:r>
+          </a:p>
+          <a:p>
+            <a:pPr>
+              <a:spcAft>
+                <a:spcPts val="600"/>
+              </a:spcAft>
+              <a:defRPr sz="1100">
+                <a:solidFill>
+                  <a:srgbClr val="1E293B"/>
+                </a:solidFill>
+              </a:defRPr>
+            </a:pPr>
+            <a:r>
+              <a:t>• Dense Head: Dropout(0.4) -&gt; Linear(4096, 128) -&gt; ReLU -&gt; Dropout(0.3) -&gt; Linear(128, 3).</a:t>
+            </a:r>
+          </a:p>
+          <a:p>
+            <a:pPr>
+              <a:spcAft>
+                <a:spcPts val="600"/>
+              </a:spcAft>
+              <a:defRPr sz="1100">
+                <a:solidFill>
+                  <a:srgbClr val="1E293B"/>
+                </a:solidFill>
+              </a:defRPr>
+            </a:pPr>
+            <a:r>
+              <a:t>• Trained with Adam optimizer (lr=5e-4) with StepLR decay.</a:t>
             </a:r>
           </a:p>
         </p:txBody>
@@ -5173,97 +5188,97 @@
               </a:defRPr>
             </a:pPr>
             <a:r>
-              <a:t>🚀 Model 2: MobileNetV2 (Transfer Learning)</a:t>
-            </a:r>
-          </a:p>
-          <a:p>
-            <a:pPr>
-              <a:spcAft>
-                <a:spcPts val="600"/>
-              </a:spcAft>
-              <a:defRPr sz="1100">
-                <a:solidFill>
-                  <a:srgbClr val="1E293B"/>
-                </a:solidFill>
-              </a:defRPr>
-            </a:pPr>
-            <a:r>
-              <a:t>• Backbone: MobileNetV2 pre-trained on ImageNet-1K (1.28M images).</a:t>
-            </a:r>
-          </a:p>
-          <a:p>
-            <a:pPr>
-              <a:spcAft>
-                <a:spcPts val="600"/>
-              </a:spcAft>
-              <a:defRPr sz="1100">
-                <a:solidFill>
-                  <a:srgbClr val="1E293B"/>
-                </a:solidFill>
-              </a:defRPr>
-            </a:pPr>
-            <a:r>
-              <a:t>• Inverted Residual Blocks with Depthwise Separable Convolutions.</a:t>
-            </a:r>
-          </a:p>
-          <a:p>
-            <a:pPr>
-              <a:spcAft>
-                <a:spcPts val="600"/>
-              </a:spcAft>
-              <a:defRPr sz="1100">
-                <a:solidFill>
-                  <a:srgbClr val="1E293B"/>
-                </a:solidFill>
-              </a:defRPr>
-            </a:pPr>
-            <a:r>
-              <a:t>• Frozen Feature Extractor: Preserves rich universal visual primitives (edges, textures, shapes).</a:t>
-            </a:r>
-          </a:p>
-          <a:p>
-            <a:pPr>
-              <a:spcAft>
-                <a:spcPts val="600"/>
-              </a:spcAft>
-              <a:defRPr sz="1100">
-                <a:solidFill>
-                  <a:srgbClr val="1E293B"/>
-                </a:solidFill>
-              </a:defRPr>
-            </a:pPr>
-            <a:r>
-              <a:t>• Custom Fine-Tuning Head:</a:t>
-            </a:r>
-          </a:p>
-          <a:p>
-            <a:pPr>
-              <a:spcAft>
-                <a:spcPts val="600"/>
-              </a:spcAft>
-              <a:defRPr sz="1100">
-                <a:solidFill>
-                  <a:srgbClr val="1E293B"/>
-                </a:solidFill>
-              </a:defRPr>
-            </a:pPr>
-            <a:r>
-              <a:t>•   • Dropout(0.2) → Linear(1280→128) → ReLU → Dropout(0.2) → Linear(128→3)</a:t>
-            </a:r>
-          </a:p>
-          <a:p>
-            <a:pPr>
-              <a:spcAft>
-                <a:spcPts val="600"/>
-              </a:spcAft>
-              <a:defRPr sz="1100">
-                <a:solidFill>
-                  <a:srgbClr val="1E293B"/>
-                </a:solidFill>
-              </a:defRPr>
-            </a:pPr>
-            <a:r>
-              <a:t>• Trainable Parameters: ~165,000 (Fast training, robust generalization).</a:t>
+              <a:t>⚡ Model 2: MobileNetV2 (Transfer)</a:t>
+            </a:r>
+          </a:p>
+          <a:p>
+            <a:pPr>
+              <a:spcAft>
+                <a:spcPts val="600"/>
+              </a:spcAft>
+              <a:defRPr sz="1100">
+                <a:solidFill>
+                  <a:srgbClr val="1E293B"/>
+                </a:solidFill>
+              </a:defRPr>
+            </a:pPr>
+            <a:r>
+              <a:t>• Pre-trained on ImageNet-1K (1.28 million images).</a:t>
+            </a:r>
+          </a:p>
+          <a:p>
+            <a:pPr>
+              <a:spcAft>
+                <a:spcPts val="600"/>
+              </a:spcAft>
+              <a:defRPr sz="1100">
+                <a:solidFill>
+                  <a:srgbClr val="1E293B"/>
+                </a:solidFill>
+              </a:defRPr>
+            </a:pPr>
+            <a:r>
+              <a:t>• Inverted residual blocks with depthwise separable convolutions.</a:t>
+            </a:r>
+          </a:p>
+          <a:p>
+            <a:pPr>
+              <a:spcAft>
+                <a:spcPts val="600"/>
+              </a:spcAft>
+              <a:defRPr sz="1100">
+                <a:solidFill>
+                  <a:srgbClr val="1E293B"/>
+                </a:solidFill>
+              </a:defRPr>
+            </a:pPr>
+            <a:r>
+              <a:t>• Frozen feature backbone to retain robust low/mid-level visual features.</a:t>
+            </a:r>
+          </a:p>
+          <a:p>
+            <a:pPr>
+              <a:spcAft>
+                <a:spcPts val="600"/>
+              </a:spcAft>
+              <a:defRPr sz="1100">
+                <a:solidFill>
+                  <a:srgbClr val="1E293B"/>
+                </a:solidFill>
+              </a:defRPr>
+            </a:pPr>
+            <a:r>
+              <a:t>• Custom dense head: Dropout(0.4) -&gt; Linear(1280, 256) -&gt; ReLU -&gt; Dropout(0.3) -&gt; Linear(256, 3).</a:t>
+            </a:r>
+          </a:p>
+          <a:p>
+            <a:pPr>
+              <a:spcAft>
+                <a:spcPts val="600"/>
+              </a:spcAft>
+              <a:defRPr sz="1100">
+                <a:solidFill>
+                  <a:srgbClr val="1E293B"/>
+                </a:solidFill>
+              </a:defRPr>
+            </a:pPr>
+            <a:r>
+              <a:t>• Optimized with Adam (lr=1e-3) with CrossEntropyLoss.</a:t>
+            </a:r>
+          </a:p>
+          <a:p>
+            <a:pPr>
+              <a:spcAft>
+                <a:spcPts val="600"/>
+              </a:spcAft>
+              <a:defRPr sz="1100">
+                <a:solidFill>
+                  <a:srgbClr val="1E293B"/>
+                </a:solidFill>
+              </a:defRPr>
+            </a:pPr>
+            <a:r>
+              <a:t>• High parameter efficiency: fast inference and superior generalizability.</a:t>
             </a:r>
           </a:p>
         </p:txBody>
@@ -5411,82 +5426,67 @@
               </a:defRPr>
             </a:pPr>
             <a:r>
-              <a:t>❓ The Closed-World Softmax Flaw</a:t>
-            </a:r>
-          </a:p>
-          <a:p>
-            <a:pPr>
-              <a:spcAft>
-                <a:spcPts val="600"/>
-              </a:spcAft>
-              <a:defRPr sz="1100">
-                <a:solidFill>
-                  <a:srgbClr val="1E293B"/>
-                </a:solidFill>
-              </a:defRPr>
-            </a:pPr>
-            <a:r>
-              <a:t>• Standard 2-class classifiers ALWAYS force predictions to sum to 100%.</a:t>
-            </a:r>
-          </a:p>
-          <a:p>
-            <a:pPr>
-              <a:spcAft>
-                <a:spcPts val="600"/>
-              </a:spcAft>
-              <a:defRPr sz="1100">
-                <a:solidFill>
-                  <a:srgbClr val="1E293B"/>
-                </a:solidFill>
-              </a:defRPr>
-            </a:pPr>
-            <a:r>
-              <a:t>• If a picture of a car, human, or laptop is uploaded:</a:t>
-            </a:r>
-          </a:p>
-          <a:p>
-            <a:pPr>
-              <a:spcAft>
-                <a:spcPts val="600"/>
-              </a:spcAft>
-              <a:defRPr sz="1100">
-                <a:solidFill>
-                  <a:srgbClr val="1E293B"/>
-                </a:solidFill>
-              </a:defRPr>
-            </a:pPr>
-            <a:r>
-              <a:t>• A 2-class model falsely claims 'Other Flowers: 75%' or 'Lily: 60%'.</a:t>
-            </a:r>
-          </a:p>
-          <a:p>
-            <a:pPr>
-              <a:spcAft>
-                <a:spcPts val="600"/>
-              </a:spcAft>
-              <a:defRPr sz="1100">
-                <a:solidFill>
-                  <a:srgbClr val="1E293B"/>
-                </a:solidFill>
-              </a:defRPr>
-            </a:pPr>
-            <a:r>
-              <a:t>• This violates real-world reliability and instructor requirements.</a:t>
-            </a:r>
-          </a:p>
-          <a:p>
-            <a:pPr>
-              <a:spcAft>
-                <a:spcPts val="600"/>
-              </a:spcAft>
-              <a:defRPr sz="1100">
-                <a:solidFill>
-                  <a:srgbClr val="1E293B"/>
-                </a:solidFill>
-              </a:defRPr>
-            </a:pPr>
-            <a:r>
-              <a:t>• Goal: Ensure Lily: 0% and Other Flowers: 0% for any non-flower object.</a:t>
+              <a:t>❌ The Closed-World Dilemma</a:t>
+            </a:r>
+          </a:p>
+          <a:p>
+            <a:pPr>
+              <a:spcAft>
+                <a:spcPts val="600"/>
+              </a:spcAft>
+              <a:defRPr sz="1100">
+                <a:solidFill>
+                  <a:srgbClr val="1E293B"/>
+                </a:solidFill>
+              </a:defRPr>
+            </a:pPr>
+            <a:r>
+              <a:t>• Standard 2-class classifiers assume every upload is a flower.</a:t>
+            </a:r>
+          </a:p>
+          <a:p>
+            <a:pPr>
+              <a:spcAft>
+                <a:spcPts val="600"/>
+              </a:spcAft>
+              <a:defRPr sz="1100">
+                <a:solidFill>
+                  <a:srgbClr val="1E293B"/>
+                </a:solidFill>
+              </a:defRPr>
+            </a:pPr>
+            <a:r>
+              <a:t>• Uploading a laptop, car, or person forces Softmax to output 100% flower confidence.</a:t>
+            </a:r>
+          </a:p>
+          <a:p>
+            <a:pPr>
+              <a:spcAft>
+                <a:spcPts val="600"/>
+              </a:spcAft>
+              <a:defRPr sz="1100">
+                <a:solidFill>
+                  <a:srgbClr val="1E293B"/>
+                </a:solidFill>
+              </a:defRPr>
+            </a:pPr>
+            <a:r>
+              <a:t>• Dangerous for real-world deployments and user trust.</a:t>
+            </a:r>
+          </a:p>
+          <a:p>
+            <a:pPr>
+              <a:spcAft>
+                <a:spcPts val="600"/>
+              </a:spcAft>
+              <a:defRPr sz="1100">
+                <a:solidFill>
+                  <a:srgbClr val="1E293B"/>
+                </a:solidFill>
+              </a:defRPr>
+            </a:pPr>
+            <a:r>
+              <a:t>• Requires explicit rejection of Out-Of-Distribution (OOD) objects.</a:t>
             </a:r>
           </a:p>
         </p:txBody>
@@ -5569,127 +5569,112 @@
               </a:defRPr>
             </a:pPr>
             <a:r>
-              <a:t>✅ Our 3-Class Open-Set Solution</a:t>
-            </a:r>
-          </a:p>
-          <a:p>
-            <a:pPr>
-              <a:spcAft>
-                <a:spcPts val="600"/>
-              </a:spcAft>
-              <a:defRPr sz="1100">
-                <a:solidFill>
-                  <a:srgbClr val="1E293B"/>
-                </a:solidFill>
-              </a:defRPr>
-            </a:pPr>
-            <a:r>
-              <a:t>• Model natively predicts [Lily, Non-Flower, Other Flowers].</a:t>
-            </a:r>
-          </a:p>
-          <a:p>
-            <a:pPr>
-              <a:spcAft>
-                <a:spcPts val="600"/>
-              </a:spcAft>
-              <a:defRPr sz="1100">
-                <a:solidFill>
-                  <a:srgbClr val="1E293B"/>
-                </a:solidFill>
-              </a:defRPr>
-            </a:pPr>
-            <a:r>
-              <a:t>• If Non-Flower confidence &gt; threshold (or highest rank):</a:t>
-            </a:r>
-          </a:p>
-          <a:p>
-            <a:pPr>
-              <a:spcAft>
-                <a:spcPts val="600"/>
-              </a:spcAft>
-              <a:defRPr sz="1100">
-                <a:solidFill>
-                  <a:srgbClr val="1E293B"/>
-                </a:solidFill>
-              </a:defRPr>
-            </a:pPr>
-            <a:r>
-              <a:t>•   • Prediction: 'Not a Flower 🚫'</a:t>
-            </a:r>
-          </a:p>
-          <a:p>
-            <a:pPr>
-              <a:spcAft>
-                <a:spcPts val="600"/>
-              </a:spcAft>
-              <a:defRPr sz="1100">
-                <a:solidFill>
-                  <a:srgbClr val="1E293B"/>
-                </a:solidFill>
-              </a:defRPr>
-            </a:pPr>
-            <a:r>
-              <a:t>•   • Lily Percentage: 0.0%</a:t>
-            </a:r>
-          </a:p>
-          <a:p>
-            <a:pPr>
-              <a:spcAft>
-                <a:spcPts val="600"/>
-              </a:spcAft>
-              <a:defRPr sz="1100">
-                <a:solidFill>
-                  <a:srgbClr val="1E293B"/>
-                </a:solidFill>
-              </a:defRPr>
-            </a:pPr>
-            <a:r>
-              <a:t>•   • Other Flowers Percentage: 0.0%</a:t>
-            </a:r>
-          </a:p>
-          <a:p>
-            <a:pPr>
-              <a:spcAft>
-                <a:spcPts val="600"/>
-              </a:spcAft>
-              <a:defRPr sz="1100">
-                <a:solidFill>
-                  <a:srgbClr val="1E293B"/>
-                </a:solidFill>
-              </a:defRPr>
-            </a:pPr>
-            <a:r>
-              <a:t>• If a Flower is detected:</a:t>
-            </a:r>
-          </a:p>
-          <a:p>
-            <a:pPr>
-              <a:spcAft>
-                <a:spcPts val="600"/>
-              </a:spcAft>
-              <a:defRPr sz="1100">
-                <a:solidFill>
-                  <a:srgbClr val="1E293B"/>
-                </a:solidFill>
-              </a:defRPr>
-            </a:pPr>
-            <a:r>
-              <a:t>•   • Normalizes probabilities between Lily and Other Flowers (sum = 100%).</a:t>
-            </a:r>
-          </a:p>
-          <a:p>
-            <a:pPr>
-              <a:spcAft>
-                <a:spcPts val="600"/>
-              </a:spcAft>
-              <a:defRPr sz="1100">
-                <a:solidFill>
-                  <a:srgbClr val="1E293B"/>
-                </a:solidFill>
-              </a:defRPr>
-            </a:pPr>
-            <a:r>
-              <a:t>• Fully integrated into Python predictor and Vercel web application!</a:t>
+              <a:t>🛡️ Our 3-Class Gatekeeper Solution</a:t>
+            </a:r>
+          </a:p>
+          <a:p>
+            <a:pPr>
+              <a:spcAft>
+                <a:spcPts val="600"/>
+              </a:spcAft>
+              <a:defRPr sz="1100">
+                <a:solidFill>
+                  <a:srgbClr val="1E293B"/>
+                </a:solidFill>
+              </a:defRPr>
+            </a:pPr>
+            <a:r>
+              <a:t>• Network outputs 3 logits: [Lily, Not a Flower, Other Flowers].</a:t>
+            </a:r>
+          </a:p>
+          <a:p>
+            <a:pPr>
+              <a:spcAft>
+                <a:spcPts val="600"/>
+              </a:spcAft>
+              <a:defRPr sz="1100">
+                <a:solidFill>
+                  <a:srgbClr val="1E293B"/>
+                </a:solidFill>
+              </a:defRPr>
+            </a:pPr>
+            <a:r>
+              <a:t>• Gating condition: If P(Not a Flower) &gt; 0.40 or is dominant:</a:t>
+            </a:r>
+          </a:p>
+          <a:p>
+            <a:pPr>
+              <a:spcAft>
+                <a:spcPts val="600"/>
+              </a:spcAft>
+              <a:defRPr sz="1100">
+                <a:solidFill>
+                  <a:srgbClr val="1E293B"/>
+                </a:solidFill>
+              </a:defRPr>
+            </a:pPr>
+            <a:r>
+              <a:t>•   • Classified as 'Not a Flower 🚫'</a:t>
+            </a:r>
+          </a:p>
+          <a:p>
+            <a:pPr>
+              <a:spcAft>
+                <a:spcPts val="600"/>
+              </a:spcAft>
+              <a:defRPr sz="1100">
+                <a:solidFill>
+                  <a:srgbClr val="1E293B"/>
+                </a:solidFill>
+              </a:defRPr>
+            </a:pPr>
+            <a:r>
+              <a:t>•   • Lily % forced to 0.0%</a:t>
+            </a:r>
+          </a:p>
+          <a:p>
+            <a:pPr>
+              <a:spcAft>
+                <a:spcPts val="600"/>
+              </a:spcAft>
+              <a:defRPr sz="1100">
+                <a:solidFill>
+                  <a:srgbClr val="1E293B"/>
+                </a:solidFill>
+              </a:defRPr>
+            </a:pPr>
+            <a:r>
+              <a:t>•   • Other Flowers % forced to 0.0%</a:t>
+            </a:r>
+          </a:p>
+          <a:p>
+            <a:pPr>
+              <a:spcAft>
+                <a:spcPts val="600"/>
+              </a:spcAft>
+              <a:defRPr sz="1100">
+                <a:solidFill>
+                  <a:srgbClr val="1E293B"/>
+                </a:solidFill>
+              </a:defRPr>
+            </a:pPr>
+            <a:r>
+              <a:t>• If flower confirmed: Softmax re-normalizes between Lily and Other Flowers (sum = 100%).</a:t>
+            </a:r>
+          </a:p>
+          <a:p>
+            <a:pPr>
+              <a:spcAft>
+                <a:spcPts val="600"/>
+              </a:spcAft>
+              <a:defRPr sz="1100">
+                <a:solidFill>
+                  <a:srgbClr val="1E293B"/>
+                </a:solidFill>
+              </a:defRPr>
+            </a:pPr>
+            <a:r>
+              <a:t>• Fully integrated in client-side ONNX web app and Python pipeline!</a:t>
             </a:r>
           </a:p>
         </p:txBody>
@@ -5754,7 +5739,7 @@
               </a:defRPr>
             </a:pPr>
             <a:r>
-              <a:t>Experimental Results &amp; Evaluation</a:t>
+              <a:t>Experimental Results &amp; Evaluation (15,276 Images)</a:t>
             </a:r>
           </a:p>
         </p:txBody>
@@ -5837,22 +5822,22 @@
               </a:defRPr>
             </a:pPr>
             <a:r>
-              <a:t>📊 Performance Metrics (Test / Validation Split)</a:t>
-            </a:r>
-          </a:p>
-          <a:p>
-            <a:pPr>
-              <a:spcAft>
-                <a:spcPts val="600"/>
-              </a:spcAft>
-              <a:defRPr sz="1100">
-                <a:solidFill>
-                  <a:srgbClr val="1E293B"/>
-                </a:solidFill>
-              </a:defRPr>
-            </a:pPr>
-            <a:r>
-              <a:t>• Metric | Custom CNN | MobileNetV2 Transfer</a:t>
+              <a:t>📊 Performance Metrics (Val Set: 3,055 Images)</a:t>
+            </a:r>
+          </a:p>
+          <a:p>
+            <a:pPr>
+              <a:spcAft>
+                <a:spcPts val="600"/>
+              </a:spcAft>
+              <a:defRPr sz="1100">
+                <a:solidFill>
+                  <a:srgbClr val="1E293B"/>
+                </a:solidFill>
+              </a:defRPr>
+            </a:pPr>
+            <a:r>
+              <a:t>• Metric | Custom CNN (Scratch) | MobileNetV2 Transfer</a:t>
             </a:r>
           </a:p>
           <a:p>
@@ -5882,97 +5867,97 @@
               </a:defRPr>
             </a:pPr>
             <a:r>
-              <a:t>• Best Validation Accuracy: 87.50% | 93.91% 🏆</a:t>
-            </a:r>
-          </a:p>
-          <a:p>
-            <a:pPr>
-              <a:spcAft>
-                <a:spcPts val="600"/>
-              </a:spcAft>
-              <a:defRPr sz="1100">
-                <a:solidFill>
-                  <a:srgbClr val="1E293B"/>
-                </a:solidFill>
-              </a:defRPr>
-            </a:pPr>
-            <a:r>
-              <a:t>• Lily Precision:           91.00% | 87.00%</a:t>
-            </a:r>
-          </a:p>
-          <a:p>
-            <a:pPr>
-              <a:spcAft>
-                <a:spcPts val="600"/>
-              </a:spcAft>
-              <a:defRPr sz="1100">
-                <a:solidFill>
-                  <a:srgbClr val="1E293B"/>
-                </a:solidFill>
-              </a:defRPr>
-            </a:pPr>
-            <a:r>
-              <a:t>• Lily Recall:              83.00% | 99.00% (Near Perfect)</a:t>
-            </a:r>
-          </a:p>
-          <a:p>
-            <a:pPr>
-              <a:spcAft>
-                <a:spcPts val="600"/>
-              </a:spcAft>
-              <a:defRPr sz="1100">
-                <a:solidFill>
-                  <a:srgbClr val="1E293B"/>
-                </a:solidFill>
-              </a:defRPr>
-            </a:pPr>
-            <a:r>
-              <a:t>• Non-Flower Precision:     85.00% | 98.00%</a:t>
-            </a:r>
-          </a:p>
-          <a:p>
-            <a:pPr>
-              <a:spcAft>
-                <a:spcPts val="600"/>
-              </a:spcAft>
-              <a:defRPr sz="1100">
-                <a:solidFill>
-                  <a:srgbClr val="1E293B"/>
-                </a:solidFill>
-              </a:defRPr>
-            </a:pPr>
-            <a:r>
-              <a:t>• Non-Flower Recall:        91.00% | 91.00%</a:t>
-            </a:r>
-          </a:p>
-          <a:p>
-            <a:pPr>
-              <a:spcAft>
-                <a:spcPts val="600"/>
-              </a:spcAft>
-              <a:defRPr sz="1100">
-                <a:solidFill>
-                  <a:srgbClr val="1E293B"/>
-                </a:solidFill>
-              </a:defRPr>
-            </a:pPr>
-            <a:r>
-              <a:t>• Other Flowers Precision:  86.00% | 100.00% (Flawless)</a:t>
-            </a:r>
-          </a:p>
-          <a:p>
-            <a:pPr>
-              <a:spcAft>
-                <a:spcPts val="600"/>
-              </a:spcAft>
-              <a:defRPr sz="1100">
-                <a:solidFill>
-                  <a:srgbClr val="1E293B"/>
-                </a:solidFill>
-              </a:defRPr>
-            </a:pPr>
-            <a:r>
-              <a:t>• Training Time:            3m 27s | 2m 03s (Apple MPS)</a:t>
+              <a:t>• Best Validation Accuracy: 75.29% | 85.11% 🏆</a:t>
+            </a:r>
+          </a:p>
+          <a:p>
+            <a:pPr>
+              <a:spcAft>
+                <a:spcPts val="600"/>
+              </a:spcAft>
+              <a:defRPr sz="1100">
+                <a:solidFill>
+                  <a:srgbClr val="1E293B"/>
+                </a:solidFill>
+              </a:defRPr>
+            </a:pPr>
+            <a:r>
+              <a:t>• Lily Precision:           71.46% | 82.41%</a:t>
+            </a:r>
+          </a:p>
+          <a:p>
+            <a:pPr>
+              <a:spcAft>
+                <a:spcPts val="600"/>
+              </a:spcAft>
+              <a:defRPr sz="1100">
+                <a:solidFill>
+                  <a:srgbClr val="1E293B"/>
+                </a:solidFill>
+              </a:defRPr>
+            </a:pPr>
+            <a:r>
+              <a:t>• Lily Recall:              83.96% | 91.01% (High Sensitivity)</a:t>
+            </a:r>
+          </a:p>
+          <a:p>
+            <a:pPr>
+              <a:spcAft>
+                <a:spcPts val="600"/>
+              </a:spcAft>
+              <a:defRPr sz="1100">
+                <a:solidFill>
+                  <a:srgbClr val="1E293B"/>
+                </a:solidFill>
+              </a:defRPr>
+            </a:pPr>
+            <a:r>
+              <a:t>• Non-Flower Precision:     76.22% | 83.23%</a:t>
+            </a:r>
+          </a:p>
+          <a:p>
+            <a:pPr>
+              <a:spcAft>
+                <a:spcPts val="600"/>
+              </a:spcAft>
+              <a:defRPr sz="1100">
+                <a:solidFill>
+                  <a:srgbClr val="1E293B"/>
+                </a:solidFill>
+              </a:defRPr>
+            </a:pPr>
+            <a:r>
+              <a:t>• Non-Flower Recall:        79.40% | 90.35% (Reliable Rejection)</a:t>
+            </a:r>
+          </a:p>
+          <a:p>
+            <a:pPr>
+              <a:spcAft>
+                <a:spcPts val="600"/>
+              </a:spcAft>
+              <a:defRPr sz="1100">
+                <a:solidFill>
+                  <a:srgbClr val="1E293B"/>
+                </a:solidFill>
+              </a:defRPr>
+            </a:pPr>
+            <a:r>
+              <a:t>• Other Flowers Precision:  79.92% | 91.35% (High Selectivity)</a:t>
+            </a:r>
+          </a:p>
+          <a:p>
+            <a:pPr>
+              <a:spcAft>
+                <a:spcPts val="600"/>
+              </a:spcAft>
+              <a:defRPr sz="1100">
+                <a:solidFill>
+                  <a:srgbClr val="1E293B"/>
+                </a:solidFill>
+              </a:defRPr>
+            </a:pPr>
+            <a:r>
+              <a:t>• Hardware Acceleration:    Apple Silicon MPS GPU</a:t>
             </a:r>
           </a:p>
         </p:txBody>
@@ -6070,67 +6055,67 @@
               </a:defRPr>
             </a:pPr>
             <a:r>
-              <a:t>• MobileNetV2 achieved 99% Lily Recall — almost zero missed lilies!</a:t>
-            </a:r>
-          </a:p>
-          <a:p>
-            <a:pPr>
-              <a:spcAft>
-                <a:spcPts val="600"/>
-              </a:spcAft>
-              <a:defRPr sz="1100">
-                <a:solidFill>
-                  <a:srgbClr val="1E293B"/>
-                </a:solidFill>
-              </a:defRPr>
-            </a:pPr>
-            <a:r>
-              <a:t>• Other Flowers precision reached 100% on MobileNetV2.</a:t>
-            </a:r>
-          </a:p>
-          <a:p>
-            <a:pPr>
-              <a:spcAft>
-                <a:spcPts val="600"/>
-              </a:spcAft>
-              <a:defRPr sz="1100">
-                <a:solidFill>
-                  <a:srgbClr val="1E293B"/>
-                </a:solidFill>
-              </a:defRPr>
-            </a:pPr>
-            <a:r>
-              <a:t>• Non-flower detection precision reached 98% on MobileNetV2.</a:t>
-            </a:r>
-          </a:p>
-          <a:p>
-            <a:pPr>
-              <a:spcAft>
-                <a:spcPts val="600"/>
-              </a:spcAft>
-              <a:defRPr sz="1100">
-                <a:solidFill>
-                  <a:srgbClr val="1E293B"/>
-                </a:solidFill>
-              </a:defRPr>
-            </a:pPr>
-            <a:r>
-              <a:t>• Custom CNN demonstrated remarkable learning capacity (87.5% from scratch).</a:t>
-            </a:r>
-          </a:p>
-          <a:p>
-            <a:pPr>
-              <a:spcAft>
-                <a:spcPts val="600"/>
-              </a:spcAft>
-              <a:defRPr sz="1100">
-                <a:solidFill>
-                  <a:srgbClr val="1E293B"/>
-                </a:solidFill>
-              </a:defRPr>
-            </a:pPr>
-            <a:r>
-              <a:t>• Transfer learning proved superior in feature representation and training speed.</a:t>
+              <a:t>• MobileNetV2 achieved 91.01% Lily Recall (942 out of 1035 lilies detected).</a:t>
+            </a:r>
+          </a:p>
+          <a:p>
+            <a:pPr>
+              <a:spcAft>
+                <a:spcPts val="600"/>
+              </a:spcAft>
+              <a:defRPr sz="1100">
+                <a:solidFill>
+                  <a:srgbClr val="1E293B"/>
+                </a:solidFill>
+              </a:defRPr>
+            </a:pPr>
+            <a:r>
+              <a:t>• Non-flower detection recall reached 90.35% (908 out of 1005 non-flowers rejected).</a:t>
+            </a:r>
+          </a:p>
+          <a:p>
+            <a:pPr>
+              <a:spcAft>
+                <a:spcPts val="600"/>
+              </a:spcAft>
+              <a:defRPr sz="1100">
+                <a:solidFill>
+                  <a:srgbClr val="1E293B"/>
+                </a:solidFill>
+              </a:defRPr>
+            </a:pPr>
+            <a:r>
+              <a:t>• Other Flowers precision reached 91.35% on MobileNetV2.</a:t>
+            </a:r>
+          </a:p>
+          <a:p>
+            <a:pPr>
+              <a:spcAft>
+                <a:spcPts val="600"/>
+              </a:spcAft>
+              <a:defRPr sz="1100">
+                <a:solidFill>
+                  <a:srgbClr val="1E293B"/>
+                </a:solidFill>
+              </a:defRPr>
+            </a:pPr>
+            <a:r>
+              <a:t>• Custom CNN achieved 75.29% validation accuracy despite complex 3-class distribution.</a:t>
+            </a:r>
+          </a:p>
+          <a:p>
+            <a:pPr>
+              <a:spcAft>
+                <a:spcPts val="600"/>
+              </a:spcAft>
+              <a:defRPr sz="1100">
+                <a:solidFill>
+                  <a:srgbClr val="1E293B"/>
+                </a:solidFill>
+              </a:defRPr>
+            </a:pPr>
+            <a:r>
+              <a:t>• Transfer learning proved significantly superior (+10% accuracy gain).</a:t>
             </a:r>
           </a:p>
         </p:txBody>
@@ -6293,7 +6278,7 @@
               </a:defRPr>
             </a:pPr>
             <a:r>
-              <a:t>• Botanical anomaly: visually atypical from common 6-petal trumpet lilies.</a:t>
+              <a:t>• Botanical anomaly: visually completely different from 6-petal trumpet lilies.</a:t>
             </a:r>
           </a:p>
           <a:p>
@@ -6323,22 +6308,22 @@
               </a:defRPr>
             </a:pPr>
             <a:r>
-              <a:t>• Traditional models misclassify Dragon Lilies as 'Other Flowers' with high confidence.</a:t>
-            </a:r>
-          </a:p>
-          <a:p>
-            <a:pPr>
-              <a:spcAft>
-                <a:spcPts val="600"/>
-              </a:spcAft>
-              <a:defRPr sz="1100">
-                <a:solidFill>
-                  <a:srgbClr val="1E293B"/>
-                </a:solidFill>
-              </a:defRPr>
-            </a:pPr>
-            <a:r>
-              <a:t>• Demonstrates the challenge of high intra-class variance in computer vision.</a:t>
+              <a:t>• Standard flower models misclassify Dragon Lilies as 'Other Flowers' or non-plants.</a:t>
+            </a:r>
+          </a:p>
+          <a:p>
+            <a:pPr>
+              <a:spcAft>
+                <a:spcPts val="600"/>
+              </a:spcAft>
+              <a:defRPr sz="1100">
+                <a:solidFill>
+                  <a:srgbClr val="1E293B"/>
+                </a:solidFill>
+              </a:defRPr>
+            </a:pPr>
+            <a:r>
+              <a:t>• Represents real-world high intra-class variance in computer vision.</a:t>
             </a:r>
           </a:p>
         </p:txBody>
@@ -6436,52 +6421,52 @@
               </a:defRPr>
             </a:pPr>
             <a:r>
-              <a:t>• Explicitly sourced Research-Grade observations of Dracunculus vulgaris.</a:t>
-            </a:r>
-          </a:p>
-          <a:p>
-            <a:pPr>
-              <a:spcAft>
-                <a:spcPts val="600"/>
-              </a:spcAft>
-              <a:defRPr sz="1100">
-                <a:solidFill>
-                  <a:srgbClr val="1E293B"/>
-                </a:solidFill>
-              </a:defRPr>
-            </a:pPr>
-            <a:r>
-              <a:t>• Incorporated Dragon Lily images into the training distribution.</a:t>
-            </a:r>
-          </a:p>
-          <a:p>
-            <a:pPr>
-              <a:spcAft>
-                <a:spcPts val="600"/>
-              </a:spcAft>
-              <a:defRPr sz="1100">
-                <a:solidFill>
-                  <a:srgbClr val="1E293B"/>
-                </a:solidFill>
-              </a:defRPr>
-            </a:pPr>
-            <a:r>
-              <a:t>• Result: MobileNetV2 correctly identifies Dragon Lily as Lily with &gt;90% confidence!</a:t>
-            </a:r>
-          </a:p>
-          <a:p>
-            <a:pPr>
-              <a:spcAft>
-                <a:spcPts val="600"/>
-              </a:spcAft>
-              <a:defRPr sz="1100">
-                <a:solidFill>
-                  <a:srgbClr val="1E293B"/>
-                </a:solidFill>
-              </a:defRPr>
-            </a:pPr>
-            <a:r>
-              <a:t>• Key Takeaway: AI model reliability depends on capturing true real-world distribution tails.</a:t>
+              <a:t>• Curated Research-Grade observations of Dracunculus vulgaris in iNaturalist.</a:t>
+            </a:r>
+          </a:p>
+          <a:p>
+            <a:pPr>
+              <a:spcAft>
+                <a:spcPts val="600"/>
+              </a:spcAft>
+              <a:defRPr sz="1100">
+                <a:solidFill>
+                  <a:srgbClr val="1E293B"/>
+                </a:solidFill>
+              </a:defRPr>
+            </a:pPr>
+            <a:r>
+              <a:t>• Included Dragon Lily samples directly into the training distribution.</a:t>
+            </a:r>
+          </a:p>
+          <a:p>
+            <a:pPr>
+              <a:spcAft>
+                <a:spcPts val="600"/>
+              </a:spcAft>
+              <a:defRPr sz="1100">
+                <a:solidFill>
+                  <a:srgbClr val="1E293B"/>
+                </a:solidFill>
+              </a:defRPr>
+            </a:pPr>
+            <a:r>
+              <a:t>• Result: MobileNetV2 accurately identifies Dragon Lily as Lily with high confidence!</a:t>
+            </a:r>
+          </a:p>
+          <a:p>
+            <a:pPr>
+              <a:spcAft>
+                <a:spcPts val="600"/>
+              </a:spcAft>
+              <a:defRPr sz="1100">
+                <a:solidFill>
+                  <a:srgbClr val="1E293B"/>
+                </a:solidFill>
+              </a:defRPr>
+            </a:pPr>
+            <a:r>
+              <a:t>• Demonstrates how thoughtful data distribution engineering solves domain edge cases.</a:t>
             </a:r>
           </a:p>
         </p:txBody>
@@ -6546,7 +6531,7 @@
               </a:defRPr>
             </a:pPr>
             <a:r>
-              <a:t>Production Deployment on Vercel</a:t>
+              <a:t>Production Deployment &amp; Crawler Compatibility</a:t>
             </a:r>
           </a:p>
         </p:txBody>
@@ -6644,67 +6629,67 @@
               </a:defRPr>
             </a:pPr>
             <a:r>
-              <a:t>• Trained PyTorch weights exported to Open Neural Network Exchange (ONNX) format.</a:t>
-            </a:r>
-          </a:p>
-          <a:p>
-            <a:pPr>
-              <a:spcAft>
-                <a:spcPts val="600"/>
-              </a:spcAft>
-              <a:defRPr sz="1100">
-                <a:solidFill>
-                  <a:srgbClr val="1E293B"/>
-                </a:solidFill>
-              </a:defRPr>
-            </a:pPr>
-            <a:r>
-              <a:t>• Custom CNN: 3.5 MB ONNX model (lightweight, mobile friendly).</a:t>
-            </a:r>
-          </a:p>
-          <a:p>
-            <a:pPr>
-              <a:spcAft>
-                <a:spcPts val="600"/>
-              </a:spcAft>
-              <a:defRPr sz="1100">
-                <a:solidFill>
-                  <a:srgbClr val="1E293B"/>
-                </a:solidFill>
-              </a:defRPr>
-            </a:pPr>
-            <a:r>
-              <a:t>• MobileNetV2: 9.1 MB ONNX model (high accuracy).</a:t>
-            </a:r>
-          </a:p>
-          <a:p>
-            <a:pPr>
-              <a:spcAft>
-                <a:spcPts val="600"/>
-              </a:spcAft>
-              <a:defRPr sz="1100">
-                <a:solidFill>
-                  <a:srgbClr val="1E293B"/>
-                </a:solidFill>
-              </a:defRPr>
-            </a:pPr>
-            <a:r>
-              <a:t>• Runs directly in the user's browser via ONNX Runtime Web (WASM execution provider).</a:t>
-            </a:r>
-          </a:p>
-          <a:p>
-            <a:pPr>
-              <a:spcAft>
-                <a:spcPts val="600"/>
-              </a:spcAft>
-              <a:defRPr sz="1100">
-                <a:solidFill>
-                  <a:srgbClr val="1E293B"/>
-                </a:solidFill>
-              </a:defRPr>
-            </a:pPr>
-            <a:r>
-              <a:t>• Zero server cost, zero inference latency, 100% user privacy.</a:t>
+              <a:t>• Trained PyTorch checkpoints exported to ONNX format.</a:t>
+            </a:r>
+          </a:p>
+          <a:p>
+            <a:pPr>
+              <a:spcAft>
+                <a:spcPts val="600"/>
+              </a:spcAft>
+              <a:defRPr sz="1100">
+                <a:solidFill>
+                  <a:srgbClr val="1E293B"/>
+                </a:solidFill>
+              </a:defRPr>
+            </a:pPr>
+            <a:r>
+              <a:t>• Custom CNN: 3.5 MB ONNX model (lightweight).</a:t>
+            </a:r>
+          </a:p>
+          <a:p>
+            <a:pPr>
+              <a:spcAft>
+                <a:spcPts val="600"/>
+              </a:spcAft>
+              <a:defRPr sz="1100">
+                <a:solidFill>
+                  <a:srgbClr val="1E293B"/>
+                </a:solidFill>
+              </a:defRPr>
+            </a:pPr>
+            <a:r>
+              <a:t>• MobileNetV2: 9.1 MB ONNX model (high precision).</a:t>
+            </a:r>
+          </a:p>
+          <a:p>
+            <a:pPr>
+              <a:spcAft>
+                <a:spcPts val="600"/>
+              </a:spcAft>
+              <a:defRPr sz="1100">
+                <a:solidFill>
+                  <a:srgbClr val="1E293B"/>
+                </a:solidFill>
+              </a:defRPr>
+            </a:pPr>
+            <a:r>
+              <a:t>• Runs directly in the user's browser via ONNX Runtime Web (WASM).</a:t>
+            </a:r>
+          </a:p>
+          <a:p>
+            <a:pPr>
+              <a:spcAft>
+                <a:spcPts val="600"/>
+              </a:spcAft>
+              <a:defRPr sz="1100">
+                <a:solidFill>
+                  <a:srgbClr val="1E293B"/>
+                </a:solidFill>
+              </a:defRPr>
+            </a:pPr>
+            <a:r>
+              <a:t>• Zero server compute costs, zero API latency, 100% user privacy.</a:t>
             </a:r>
           </a:p>
         </p:txBody>
@@ -6787,112 +6772,127 @@
               </a:defRPr>
             </a:pPr>
             <a:r>
-              <a:t>🌐 Frontend &amp; Instructor Download Hub</a:t>
-            </a:r>
-          </a:p>
-          <a:p>
-            <a:pPr>
-              <a:spcAft>
-                <a:spcPts val="600"/>
-              </a:spcAft>
-              <a:defRPr sz="1100">
-                <a:solidFill>
-                  <a:srgbClr val="1E293B"/>
-                </a:solidFill>
-              </a:defRPr>
-            </a:pPr>
-            <a:r>
-              <a:t>• Responsive modern UI with drag-and-drop image upload.</a:t>
-            </a:r>
-          </a:p>
-          <a:p>
-            <a:pPr>
-              <a:spcAft>
-                <a:spcPts val="600"/>
-              </a:spcAft>
-              <a:defRPr sz="1100">
-                <a:solidFill>
-                  <a:srgbClr val="1E293B"/>
-                </a:solidFill>
-              </a:defRPr>
-            </a:pPr>
-            <a:r>
-              <a:t>• Side-by-side comparison cards for Custom CNN vs MobileNetV2.</a:t>
-            </a:r>
-          </a:p>
-          <a:p>
-            <a:pPr>
-              <a:spcAft>
-                <a:spcPts val="600"/>
-              </a:spcAft>
-              <a:defRPr sz="1100">
-                <a:solidFill>
-                  <a:srgbClr val="1E293B"/>
-                </a:solidFill>
-              </a:defRPr>
-            </a:pPr>
-            <a:r>
-              <a:t>• Integrated Instructor Resource Center with one-click direct download buttons:</a:t>
-            </a:r>
-          </a:p>
-          <a:p>
-            <a:pPr>
-              <a:spcAft>
-                <a:spcPts val="600"/>
-              </a:spcAft>
-              <a:defRPr sz="1100">
-                <a:solidFill>
-                  <a:srgbClr val="1E293B"/>
-                </a:solidFill>
-              </a:defRPr>
-            </a:pPr>
-            <a:r>
-              <a:t>•   • 📦 Download Dataset ZIP (35 MB)</a:t>
-            </a:r>
-          </a:p>
-          <a:p>
-            <a:pPr>
-              <a:spcAft>
-                <a:spcPts val="600"/>
-              </a:spcAft>
-              <a:defRPr sz="1100">
-                <a:solidFill>
-                  <a:srgbClr val="1E293B"/>
-                </a:solidFill>
-              </a:defRPr>
-            </a:pPr>
-            <a:r>
-              <a:t>•   • 📄 Download Project Report (PDF &amp; DOCX)</a:t>
-            </a:r>
-          </a:p>
-          <a:p>
-            <a:pPr>
-              <a:spcAft>
-                <a:spcPts val="600"/>
-              </a:spcAft>
-              <a:defRPr sz="1100">
-                <a:solidFill>
-                  <a:srgbClr val="1E293B"/>
-                </a:solidFill>
-              </a:defRPr>
-            </a:pPr>
-            <a:r>
-              <a:t>•   • 📊 Download Presentation Slides (PPTX)</a:t>
-            </a:r>
-          </a:p>
-          <a:p>
-            <a:pPr>
-              <a:spcAft>
-                <a:spcPts val="600"/>
-              </a:spcAft>
-              <a:defRPr sz="1100">
-                <a:solidFill>
-                  <a:srgbClr val="1E293B"/>
-                </a:solidFill>
-              </a:defRPr>
-            </a:pPr>
-            <a:r>
-              <a:t>•   • 💼 View LinkedIn Post (https://lnkd.in/p/d3C-vc7q) &amp; GitHub Repository</a:t>
+              <a:t>🌐 Submission Hub &amp; Automated Crawler Ready</a:t>
+            </a:r>
+          </a:p>
+          <a:p>
+            <a:pPr>
+              <a:spcAft>
+                <a:spcPts val="600"/>
+              </a:spcAft>
+              <a:defRPr sz="1100">
+                <a:solidFill>
+                  <a:srgbClr val="1E293B"/>
+                </a:solidFill>
+              </a:defRPr>
+            </a:pPr>
+            <a:r>
+              <a:t>• Modern responsive UI with drag-and-drop inference.</a:t>
+            </a:r>
+          </a:p>
+          <a:p>
+            <a:pPr>
+              <a:spcAft>
+                <a:spcPts val="600"/>
+              </a:spcAft>
+              <a:defRPr sz="1100">
+                <a:solidFill>
+                  <a:srgbClr val="1E293B"/>
+                </a:solidFill>
+              </a:defRPr>
+            </a:pPr>
+            <a:r>
+              <a:t>• Side-by-side comparison cards with real-time probability meters.</a:t>
+            </a:r>
+          </a:p>
+          <a:p>
+            <a:pPr>
+              <a:spcAft>
+                <a:spcPts val="600"/>
+              </a:spcAft>
+              <a:defRPr sz="1100">
+                <a:solidFill>
+                  <a:srgbClr val="1E293B"/>
+                </a:solidFill>
+              </a:defRPr>
+            </a:pPr>
+            <a:r>
+              <a:t>• Automated evaluation links accessible directly on frontend:</a:t>
+            </a:r>
+          </a:p>
+          <a:p>
+            <a:pPr>
+              <a:spcAft>
+                <a:spcPts val="600"/>
+              </a:spcAft>
+              <a:defRPr sz="1100">
+                <a:solidFill>
+                  <a:srgbClr val="1E293B"/>
+                </a:solidFill>
+              </a:defRPr>
+            </a:pPr>
+            <a:r>
+              <a:t>•   • 📦 Dataset Download ZIP &amp; Full 15k Script</a:t>
+            </a:r>
+          </a:p>
+          <a:p>
+            <a:pPr>
+              <a:spcAft>
+                <a:spcPts val="600"/>
+              </a:spcAft>
+              <a:defRPr sz="1100">
+                <a:solidFill>
+                  <a:srgbClr val="1E293B"/>
+                </a:solidFill>
+              </a:defRPr>
+            </a:pPr>
+            <a:r>
+              <a:t>•   • 📄 Project Report (PDF &amp; Word)</a:t>
+            </a:r>
+          </a:p>
+          <a:p>
+            <a:pPr>
+              <a:spcAft>
+                <a:spcPts val="600"/>
+              </a:spcAft>
+              <a:defRPr sz="1100">
+                <a:solidFill>
+                  <a:srgbClr val="1E293B"/>
+                </a:solidFill>
+              </a:defRPr>
+            </a:pPr>
+            <a:r>
+              <a:t>•   • 📊 Presentation Slides (PPTX)</a:t>
+            </a:r>
+          </a:p>
+          <a:p>
+            <a:pPr>
+              <a:spcAft>
+                <a:spcPts val="600"/>
+              </a:spcAft>
+              <a:defRPr sz="1100">
+                <a:solidFill>
+                  <a:srgbClr val="1E293B"/>
+                </a:solidFill>
+              </a:defRPr>
+            </a:pPr>
+            <a:r>
+              <a:t>•   • 🧠 Downloadable Model Weights (.pth)</a:t>
+            </a:r>
+          </a:p>
+          <a:p>
+            <a:pPr>
+              <a:spcAft>
+                <a:spcPts val="600"/>
+              </a:spcAft>
+              <a:defRPr sz="1100">
+                <a:solidFill>
+                  <a:srgbClr val="1E293B"/>
+                </a:solidFill>
+              </a:defRPr>
+            </a:pPr>
+            <a:r>
+              <a:t>•   • 💼 LinkedIn Post &amp; GitHub Source Code</a:t>
             </a:r>
           </a:p>
         </p:txBody>

</xml_diff>